<commit_message>
fix(deck): V4 final wording and numbering corrections
Slide 4: explicit NOT VERIFIED / UNKNOWN labels for unit price, pack size and
weekly-plan variety terms. Slide 6: continuous checkpoint numbers 1-3 with the
real week labels kept. Slide 3: clearer chart caption (keyword mentions, not
survey results or sentiment scores). Slides 1, 2 and 5 are unchanged.

Co-Authored-By: Claude Sonnet 5.5 <noreply@anthropic.com>
</commit_message>
<xml_diff>
--- a/demo_data/saved_runs/20261014-201109-cold-pressed-juice-subscriptio-c0fe/deck/launchscout-pitch-deck-PARTIAL.pptx
+++ b/demo_data/saved_runs/20261014-201109-cold-pressed-juice-subscriptio-c0fe/deck/launchscout-pitch-deck-PARTIAL.pptx
@@ -1374,6 +1374,11 @@
           <a:p>
             <a:r>
               <a:t>- Full text of items shortened on the slide:</a:t>
+            </a:r>
+          </a:p>
+          <a:p>
+            <a:r>
+              <a:t>-   iBites: Describes Pune delivery, including Baner, Kothrud, Viman Nagar, Hinjawadi and Pune Camp</a:t>
             </a:r>
           </a:p>
           <a:p>
@@ -10289,7 +10294,7 @@
                 </a:solidFill>
                 <a:latin typeface="Calibri"/>
               </a:rPr>
-              <a:t>Keyword mentions across 8 retrieved testimonial(s). A theme count is not a sentiment score.</a:t>
+              <a:t>Keyword mentions across 8 retrieved testimonials. Theme counts are not independent customer survey results or sentiment scores.</a:t>
             </a:r>
           </a:p>
         </p:txBody>
@@ -12062,11 +12067,11 @@
         <p:spPr>
           <a:xfrm>
             <a:off x="411480" y="2453640"/>
-            <a:ext cx="2595295" cy="2694432"/>
+            <a:ext cx="2595295" cy="2438400"/>
           </a:xfrm>
           <a:prstGeom prst="roundRect">
             <a:avLst>
-              <a:gd name="adj" fmla="val 2818"/>
+              <a:gd name="adj" fmla="val 3000"/>
             </a:avLst>
           </a:prstGeom>
           <a:solidFill>
@@ -12362,7 +12367,7 @@
         <p:spPr>
           <a:xfrm>
             <a:off x="576072" y="3624072"/>
-            <a:ext cx="2266111" cy="1432560"/>
+            <a:ext cx="2266111" cy="1176528"/>
           </a:xfrm>
           <a:prstGeom prst="rect">
             <a:avLst/>
@@ -12388,7 +12393,7 @@
                 </a:solidFill>
                 <a:latin typeface="Calibri"/>
               </a:rPr>
-              <a:t>iBites: Describes Pune delivery, including Baner, Kothrud, Viman Nagar, Hinjawadi and Pune Camp</a:t>
+              <a:t>iBites: Describes Pune delivery, including Baner, Kothrud, Viman Nagar</a:t>
             </a:r>
           </a:p>
           <a:p>
@@ -12418,7 +12423,7 @@
         </p:nvCxnSpPr>
         <p:spPr>
           <a:xfrm>
-            <a:off x="3034207" y="3800856"/>
+            <a:off x="3034207" y="3672840"/>
             <a:ext cx="274320" cy="0"/>
           </a:xfrm>
           <a:prstGeom prst="line">
@@ -12455,11 +12460,11 @@
         <p:spPr>
           <a:xfrm>
             <a:off x="3335959" y="2453640"/>
-            <a:ext cx="2595295" cy="2694432"/>
+            <a:ext cx="2595295" cy="2438400"/>
           </a:xfrm>
           <a:prstGeom prst="roundRect">
             <a:avLst>
-              <a:gd name="adj" fmla="val 2818"/>
+              <a:gd name="adj" fmla="val 3000"/>
             </a:avLst>
           </a:prstGeom>
           <a:solidFill>
@@ -12711,7 +12716,7 @@
         <p:spPr>
           <a:xfrm>
             <a:off x="3500551" y="3624072"/>
-            <a:ext cx="2266111" cy="1432560"/>
+            <a:ext cx="2266111" cy="1176528"/>
           </a:xfrm>
           <a:prstGeom prst="rect">
             <a:avLst/>
@@ -12767,7 +12772,7 @@
         </p:nvCxnSpPr>
         <p:spPr>
           <a:xfrm>
-            <a:off x="5958687" y="3800856"/>
+            <a:off x="5958687" y="3672840"/>
             <a:ext cx="274320" cy="0"/>
           </a:xfrm>
           <a:prstGeom prst="line">
@@ -12804,11 +12809,11 @@
         <p:spPr>
           <a:xfrm>
             <a:off x="6260439" y="2453640"/>
-            <a:ext cx="2595295" cy="2694432"/>
+            <a:ext cx="2595295" cy="2438400"/>
           </a:xfrm>
           <a:prstGeom prst="roundRect">
             <a:avLst>
-              <a:gd name="adj" fmla="val 2818"/>
+              <a:gd name="adj" fmla="val 3000"/>
             </a:avLst>
           </a:prstGeom>
           <a:solidFill>
@@ -13016,7 +13021,7 @@
         <p:spPr>
           <a:xfrm>
             <a:off x="6425031" y="3624072"/>
-            <a:ext cx="2266111" cy="1432560"/>
+            <a:ext cx="2266111" cy="1176528"/>
           </a:xfrm>
           <a:prstGeom prst="rect">
             <a:avLst/>
@@ -13072,7 +13077,7 @@
         </p:nvCxnSpPr>
         <p:spPr>
           <a:xfrm>
-            <a:off x="8883167" y="3800856"/>
+            <a:off x="8883167" y="3672840"/>
             <a:ext cx="274320" cy="0"/>
           </a:xfrm>
           <a:prstGeom prst="line">
@@ -13109,11 +13114,11 @@
         <p:spPr>
           <a:xfrm>
             <a:off x="9184919" y="2453640"/>
-            <a:ext cx="2595295" cy="2694432"/>
+            <a:ext cx="2595295" cy="2438400"/>
           </a:xfrm>
           <a:prstGeom prst="roundRect">
             <a:avLst>
-              <a:gd name="adj" fmla="val 2818"/>
+              <a:gd name="adj" fmla="val 3000"/>
             </a:avLst>
           </a:prstGeom>
           <a:solidFill>
@@ -13321,7 +13326,7 @@
         <p:spPr>
           <a:xfrm>
             <a:off x="9349511" y="3624072"/>
-            <a:ext cx="2266111" cy="1432560"/>
+            <a:ext cx="2266111" cy="1176528"/>
           </a:xfrm>
           <a:prstGeom prst="rect">
             <a:avLst/>
@@ -13377,12 +13382,12 @@
         </p:nvSpPr>
         <p:spPr>
           <a:xfrm>
-            <a:off x="411480" y="5285232"/>
-            <a:ext cx="11368735" cy="749808"/>
+            <a:off x="411480" y="5029200"/>
+            <a:ext cx="11368735" cy="1005840"/>
           </a:xfrm>
           <a:prstGeom prst="roundRect">
             <a:avLst>
-              <a:gd name="adj" fmla="val 9756"/>
+              <a:gd name="adj" fmla="val 7272"/>
             </a:avLst>
           </a:prstGeom>
           <a:solidFill>
@@ -13425,8 +13430,8 @@
         </p:nvSpPr>
         <p:spPr>
           <a:xfrm>
-            <a:off x="594360" y="5358384"/>
-            <a:ext cx="1554480" cy="603503"/>
+            <a:off x="594360" y="5102352"/>
+            <a:ext cx="1554480" cy="859536"/>
           </a:xfrm>
           <a:prstGeom prst="rect">
             <a:avLst/>
@@ -13474,18 +13479,18 @@
       </p:sp>
       <p:sp>
         <p:nvSpPr>
-          <p:cNvPr id="48" name="Unknown: iBites: verified unit price and pack size"/>
+          <p:cNvPr id="48" name="Unknown: iBites: Unit price and pack size NOT VERIFIED"/>
           <p:cNvSpPr/>
           <p:nvPr/>
         </p:nvSpPr>
         <p:spPr>
           <a:xfrm>
-            <a:off x="2240280" y="5394960"/>
-            <a:ext cx="3956113" cy="274320"/>
+            <a:off x="2240280" y="5157216"/>
+            <a:ext cx="4609947" cy="292608"/>
           </a:xfrm>
           <a:prstGeom prst="roundRect">
             <a:avLst>
-              <a:gd name="adj" fmla="val 50000"/>
+              <a:gd name="adj" fmla="val 25000"/>
             </a:avLst>
           </a:prstGeom>
           <a:solidFill>
@@ -13513,7 +13518,7 @@
           </a:fontRef>
         </p:style>
         <p:txBody>
-          <a:bodyPr rtlCol="0" anchor="ctr" wrap="none" lIns="146304" rIns="146304" tIns="54864" bIns="54864"/>
+          <a:bodyPr rtlCol="0" anchor="ctr" wrap="none" lIns="73152" rIns="73152" tIns="54864" bIns="54864"/>
           <a:lstStyle/>
           <a:p>
             <a:pPr algn="ctr">
@@ -13528,25 +13533,25 @@
                 </a:solidFill>
                 <a:latin typeface="Calibri"/>
               </a:rPr>
-              <a:t>iBites: verified unit price and pack size</a:t>
-            </a:r>
-          </a:p>
-        </p:txBody>
-      </p:sp>
-      <p:sp>
-        <p:nvSpPr>
-          <p:cNvPr id="49" name="Unknown: Earth Organic Juices: verified unit price and pack size"/>
+              <a:t>iBites: Unit price and pack size NOT VERIFIED</a:t>
+            </a:r>
+          </a:p>
+        </p:txBody>
+      </p:sp>
+      <p:sp>
+        <p:nvSpPr>
+          <p:cNvPr id="49" name="Unknown: Earth Organic Juices: Unit price and pack size NOT VERIFIED"/>
           <p:cNvSpPr/>
           <p:nvPr/>
         </p:nvSpPr>
         <p:spPr>
           <a:xfrm>
-            <a:off x="6287833" y="5394960"/>
-            <a:ext cx="5169598" cy="274320"/>
+            <a:off x="6987387" y="5157216"/>
+            <a:ext cx="4609947" cy="292608"/>
           </a:xfrm>
           <a:prstGeom prst="roundRect">
             <a:avLst>
-              <a:gd name="adj" fmla="val 50000"/>
+              <a:gd name="adj" fmla="val 25000"/>
             </a:avLst>
           </a:prstGeom>
           <a:solidFill>
@@ -13574,7 +13579,7 @@
           </a:fontRef>
         </p:style>
         <p:txBody>
-          <a:bodyPr rtlCol="0" anchor="ctr" wrap="none" lIns="146304" rIns="146304" tIns="54864" bIns="54864"/>
+          <a:bodyPr rtlCol="0" anchor="ctr" wrap="none" lIns="73152" rIns="73152" tIns="54864" bIns="54864"/>
           <a:lstStyle/>
           <a:p>
             <a:pPr algn="ctr">
@@ -13589,25 +13594,25 @@
                 </a:solidFill>
                 <a:latin typeface="Calibri"/>
               </a:rPr>
-              <a:t>Earth Organic Juices: verified unit price and pack size</a:t>
-            </a:r>
-          </a:p>
-        </p:txBody>
-      </p:sp>
-      <p:sp>
-        <p:nvSpPr>
-          <p:cNvPr id="50" name="Unknown: Earth Organic Juices' weekly-plan variety terms are unknown"/>
+              <a:t>Earth Organic Juices: Unit price and pack size NOT VERIFIED</a:t>
+            </a:r>
+          </a:p>
+        </p:txBody>
+      </p:sp>
+      <p:sp>
+        <p:nvSpPr>
+          <p:cNvPr id="50" name="Unknown: Earth Organic Juices: Weekly-plan variety terms UNKNOWN"/>
           <p:cNvSpPr/>
           <p:nvPr/>
         </p:nvSpPr>
         <p:spPr>
           <a:xfrm>
-            <a:off x="2240280" y="5742432"/>
-            <a:ext cx="5516308" cy="274320"/>
+            <a:off x="2240280" y="5522976"/>
+            <a:ext cx="4609947" cy="292608"/>
           </a:xfrm>
           <a:prstGeom prst="roundRect">
             <a:avLst>
-              <a:gd name="adj" fmla="val 50000"/>
+              <a:gd name="adj" fmla="val 25000"/>
             </a:avLst>
           </a:prstGeom>
           <a:solidFill>
@@ -13635,7 +13640,7 @@
           </a:fontRef>
         </p:style>
         <p:txBody>
-          <a:bodyPr rtlCol="0" anchor="ctr" wrap="none" lIns="146304" rIns="146304" tIns="54864" bIns="54864"/>
+          <a:bodyPr rtlCol="0" anchor="ctr" wrap="none" lIns="73152" rIns="73152" tIns="54864" bIns="54864"/>
           <a:lstStyle/>
           <a:p>
             <a:pPr algn="ctr">
@@ -13650,7 +13655,7 @@
                 </a:solidFill>
                 <a:latin typeface="Calibri"/>
               </a:rPr>
-              <a:t>Earth Organic Juices' weekly-plan variety terms are unknown</a:t>
+              <a:t>Earth Organic Juices: Weekly-plan variety terms UNKNOWN</a:t>
             </a:r>
           </a:p>
         </p:txBody>
@@ -17516,7 +17521,7 @@
                 </a:solidFill>
                 <a:latin typeface="Georgia"/>
               </a:rPr>
-              <a:t>3</a:t>
+              <a:t>2</a:t>
             </a:r>
           </a:p>
         </p:txBody>
@@ -17628,7 +17633,7 @@
                 </a:solidFill>
                 <a:latin typeface="Georgia"/>
               </a:rPr>
-              <a:t>4</a:t>
+              <a:t>3</a:t>
             </a:r>
           </a:p>
         </p:txBody>

</xml_diff>